<commit_message>
Fill in the contributions slide
Replaces the three placeholders with the agreed split of the deck:

  Ximin Zeng     slides 1-5, 19-20   problem framing, the data, closing
  Ansley Smith   slides 6-12         the method, and the sorted-file fix
  Rebecca Drake  slides 13-18        accuracy, interpretation, RAM and speed

Cards are ordered by slide number so the slide reads in the same order as the
talk.

Co-Authored-By: Claude Opus 5 <noreply@anthropic.com>
</commit_message>
<xml_diff>
--- a/presentation/Group7_Assignment1_Incremental_Learning.pptx
+++ b/presentation/Group7_Assignment1_Incremental_Learning.pptx
@@ -1610,7 +1610,7 @@
           <a:lstStyle/>
           <a:p>
             <a:r>
-              <a:t>Fill this in as a team before submitting.</a:t>
+              <a:t>We split the deck three ways: Ximin sets up the problem and closes, Ansley covers how the method works, Rebecca covers what we found.</a:t>
             </a:r>
           </a:p>
         </p:txBody>
@@ -9629,8 +9629,8 @@
         </p:nvSpPr>
         <p:spPr>
           <a:xfrm>
-            <a:off x="594360" y="1828800"/>
-            <a:ext cx="3520440" cy="3840480"/>
+            <a:off x="594360" y="1783080"/>
+            <a:ext cx="3520440" cy="4114800"/>
           </a:xfrm>
           <a:prstGeom prst="roundRect">
             <a:avLst>
@@ -9675,8 +9675,8 @@
         </p:nvSpPr>
         <p:spPr>
           <a:xfrm>
-            <a:off x="1842516" y="2148840"/>
-            <a:ext cx="1024128" cy="1024128"/>
+            <a:off x="1874519" y="2057400"/>
+            <a:ext cx="960120" cy="960120"/>
           </a:xfrm>
           <a:prstGeom prst="ellipse">
             <a:avLst/>
@@ -9711,13 +9711,13 @@
           <a:p>
             <a:pPr algn="ctr"/>
             <a:r>
-              <a:rPr sz="3000" b="1">
+              <a:rPr sz="2800" b="1">
                 <a:solidFill>
                   <a:srgbClr val="FFFFFF"/>
                 </a:solidFill>
                 <a:latin typeface="Cambria"/>
               </a:rPr>
-              <a:t>AS</a:t>
+              <a:t>XZ</a:t>
             </a:r>
           </a:p>
         </p:txBody>
@@ -9730,8 +9730,8 @@
         </p:nvSpPr>
         <p:spPr>
           <a:xfrm>
-            <a:off x="731520" y="3364992"/>
-            <a:ext cx="3246120" cy="411480"/>
+            <a:off x="731520" y="3182112"/>
+            <a:ext cx="3246120" cy="384048"/>
           </a:xfrm>
           <a:prstGeom prst="rect">
             <a:avLst/>
@@ -9750,13 +9750,13 @@
               </a:lnSpc>
             </a:pPr>
             <a:r>
-              <a:rPr sz="2000" b="1" i="0">
+              <a:rPr sz="1900" b="1" i="0">
                 <a:solidFill>
                   <a:srgbClr val="0B2E33"/>
                 </a:solidFill>
                 <a:latin typeface="Calibri"/>
               </a:rPr>
-              <a:t>Ansley Smith</a:t>
+              <a:t>Ximin Zeng</a:t>
             </a:r>
           </a:p>
         </p:txBody>
@@ -9769,8 +9769,8 @@
         </p:nvSpPr>
         <p:spPr>
           <a:xfrm>
-            <a:off x="777240" y="3886200"/>
-            <a:ext cx="3154680" cy="1554480"/>
+            <a:off x="731520" y="3611880"/>
+            <a:ext cx="3246120" cy="320040"/>
           </a:xfrm>
           <a:prstGeom prst="rect">
             <a:avLst/>
@@ -9785,31 +9785,111 @@
           <a:p>
             <a:pPr algn="ctr">
               <a:lnSpc>
-                <a:spcPct val="120000"/>
-              </a:lnSpc>
-            </a:pPr>
-            <a:r>
-              <a:rPr sz="1500" b="0" i="1">
-                <a:solidFill>
-                  <a:srgbClr val="557575"/>
+                <a:spcPct val="100000"/>
+              </a:lnSpc>
+            </a:pPr>
+            <a:r>
+              <a:rPr sz="1400" b="1" i="0">
+                <a:solidFill>
+                  <a:srgbClr val="C9502F"/>
                 </a:solidFill>
                 <a:latin typeface="Calibri"/>
               </a:rPr>
-              <a:t>Fill in before submitting</a:t>
-            </a:r>
-          </a:p>
-        </p:txBody>
-      </p:sp>
-      <p:sp>
-        <p:nvSpPr>
-          <p:cNvPr id="8" name="Rounded Rectangle 7"/>
+              <a:t>Slides 1–5, 19–20</a:t>
+            </a:r>
+          </a:p>
+        </p:txBody>
+      </p:sp>
+      <p:sp>
+        <p:nvSpPr>
+          <p:cNvPr id="8" name="TextBox 7"/>
+          <p:cNvSpPr txBox="1"/>
+          <p:nvPr/>
+        </p:nvSpPr>
+        <p:spPr>
+          <a:xfrm>
+            <a:off x="868680" y="4160520"/>
+            <a:ext cx="2971800" cy="1554480"/>
+          </a:xfrm>
+          <a:prstGeom prst="rect">
+            <a:avLst/>
+          </a:prstGeom>
+          <a:noFill/>
+        </p:spPr>
+        <p:txBody>
+          <a:bodyPr wrap="square" anchor="t" lIns="0" rIns="0" tIns="0" bIns="0">
+            <a:spAutoFit/>
+          </a:bodyPr>
+          <a:lstStyle/>
+          <a:p>
+            <a:pPr algn="l">
+              <a:lnSpc>
+                <a:spcPct val="115000"/>
+              </a:lnSpc>
+              <a:spcAft>
+                <a:spcPts val="1100"/>
+              </a:spcAft>
+            </a:pPr>
+            <a:r>
+              <a:rPr sz="1400" b="0" i="0">
+                <a:solidFill>
+                  <a:srgbClr val="1C3738"/>
+                </a:solidFill>
+                <a:latin typeface="Calibri"/>
+              </a:rPr>
+              <a:t>•  Framing the problem and the data</a:t>
+            </a:r>
+          </a:p>
+          <a:p>
+            <a:pPr algn="l">
+              <a:lnSpc>
+                <a:spcPct val="115000"/>
+              </a:lnSpc>
+              <a:spcAft>
+                <a:spcPts val="1100"/>
+              </a:spcAft>
+            </a:pPr>
+            <a:r>
+              <a:rPr sz="1400" b="0" i="0">
+                <a:solidFill>
+                  <a:srgbClr val="1C3738"/>
+                </a:solidFill>
+                <a:latin typeface="Calibri"/>
+              </a:rPr>
+              <a:t>•  Why the file could not be opened</a:t>
+            </a:r>
+          </a:p>
+          <a:p>
+            <a:pPr algn="l">
+              <a:lnSpc>
+                <a:spcPct val="115000"/>
+              </a:lnSpc>
+              <a:spcAft>
+                <a:spcPts val="1100"/>
+              </a:spcAft>
+            </a:pPr>
+            <a:r>
+              <a:rPr sz="1400" b="0" i="0">
+                <a:solidFill>
+                  <a:srgbClr val="1C3738"/>
+                </a:solidFill>
+                <a:latin typeface="Calibri"/>
+              </a:rPr>
+              <a:t>•  Closing and next steps</a:t>
+            </a:r>
+          </a:p>
+        </p:txBody>
+      </p:sp>
+      <p:sp>
+        <p:nvSpPr>
+          <p:cNvPr id="9" name="Rounded Rectangle 8"/>
           <p:cNvSpPr/>
           <p:nvPr/>
         </p:nvSpPr>
         <p:spPr>
           <a:xfrm>
-            <a:off x="4389120" y="1828800"/>
-            <a:ext cx="3520440" cy="3840480"/>
+            <a:off x="4389120" y="1783080"/>
+            <a:ext cx="3520440" cy="4114800"/>
           </a:xfrm>
           <a:prstGeom prst="roundRect">
             <a:avLst>
@@ -9848,14 +9928,14 @@
       </p:sp>
       <p:sp>
         <p:nvSpPr>
-          <p:cNvPr id="9" name="Oval 8"/>
+          <p:cNvPr id="10" name="Oval 9"/>
           <p:cNvSpPr/>
           <p:nvPr/>
         </p:nvSpPr>
         <p:spPr>
           <a:xfrm>
-            <a:off x="5637276" y="2148840"/>
-            <a:ext cx="1024128" cy="1024128"/>
+            <a:off x="5669280" y="2057400"/>
+            <a:ext cx="960120" cy="960120"/>
           </a:xfrm>
           <a:prstGeom prst="ellipse">
             <a:avLst/>
@@ -9890,27 +9970,27 @@
           <a:p>
             <a:pPr algn="ctr"/>
             <a:r>
-              <a:rPr sz="3000" b="1">
+              <a:rPr sz="2800" b="1">
                 <a:solidFill>
                   <a:srgbClr val="FFFFFF"/>
                 </a:solidFill>
                 <a:latin typeface="Cambria"/>
               </a:rPr>
-              <a:t>RD</a:t>
-            </a:r>
-          </a:p>
-        </p:txBody>
-      </p:sp>
-      <p:sp>
-        <p:nvSpPr>
-          <p:cNvPr id="10" name="TextBox 9"/>
+              <a:t>AS</a:t>
+            </a:r>
+          </a:p>
+        </p:txBody>
+      </p:sp>
+      <p:sp>
+        <p:nvSpPr>
+          <p:cNvPr id="11" name="TextBox 10"/>
           <p:cNvSpPr txBox="1"/>
           <p:nvPr/>
         </p:nvSpPr>
         <p:spPr>
           <a:xfrm>
-            <a:off x="4526280" y="3364992"/>
-            <a:ext cx="3246120" cy="411480"/>
+            <a:off x="4526280" y="3182112"/>
+            <a:ext cx="3246120" cy="384048"/>
           </a:xfrm>
           <a:prstGeom prst="rect">
             <a:avLst/>
@@ -9929,27 +10009,27 @@
               </a:lnSpc>
             </a:pPr>
             <a:r>
-              <a:rPr sz="2000" b="1" i="0">
+              <a:rPr sz="1900" b="1" i="0">
                 <a:solidFill>
                   <a:srgbClr val="0B2E33"/>
                 </a:solidFill>
                 <a:latin typeface="Calibri"/>
               </a:rPr>
-              <a:t>Rebecca Drake</a:t>
-            </a:r>
-          </a:p>
-        </p:txBody>
-      </p:sp>
-      <p:sp>
-        <p:nvSpPr>
-          <p:cNvPr id="11" name="TextBox 10"/>
+              <a:t>Ansley Smith</a:t>
+            </a:r>
+          </a:p>
+        </p:txBody>
+      </p:sp>
+      <p:sp>
+        <p:nvSpPr>
+          <p:cNvPr id="12" name="TextBox 11"/>
           <p:cNvSpPr txBox="1"/>
           <p:nvPr/>
         </p:nvSpPr>
         <p:spPr>
           <a:xfrm>
-            <a:off x="4572000" y="3886200"/>
-            <a:ext cx="3154680" cy="1554480"/>
+            <a:off x="4526280" y="3611880"/>
+            <a:ext cx="3246120" cy="320040"/>
           </a:xfrm>
           <a:prstGeom prst="rect">
             <a:avLst/>
@@ -9964,31 +10044,111 @@
           <a:p>
             <a:pPr algn="ctr">
               <a:lnSpc>
-                <a:spcPct val="120000"/>
-              </a:lnSpc>
-            </a:pPr>
-            <a:r>
-              <a:rPr sz="1500" b="0" i="1">
-                <a:solidFill>
-                  <a:srgbClr val="557575"/>
+                <a:spcPct val="100000"/>
+              </a:lnSpc>
+            </a:pPr>
+            <a:r>
+              <a:rPr sz="1400" b="1" i="0">
+                <a:solidFill>
+                  <a:srgbClr val="C9502F"/>
                 </a:solidFill>
                 <a:latin typeface="Calibri"/>
               </a:rPr>
-              <a:t>Fill in before submitting</a:t>
-            </a:r>
-          </a:p>
-        </p:txBody>
-      </p:sp>
-      <p:sp>
-        <p:nvSpPr>
-          <p:cNvPr id="12" name="Rounded Rectangle 11"/>
+              <a:t>Slides 6–12</a:t>
+            </a:r>
+          </a:p>
+        </p:txBody>
+      </p:sp>
+      <p:sp>
+        <p:nvSpPr>
+          <p:cNvPr id="13" name="TextBox 12"/>
+          <p:cNvSpPr txBox="1"/>
+          <p:nvPr/>
+        </p:nvSpPr>
+        <p:spPr>
+          <a:xfrm>
+            <a:off x="4663440" y="4160520"/>
+            <a:ext cx="2971800" cy="1554480"/>
+          </a:xfrm>
+          <a:prstGeom prst="rect">
+            <a:avLst/>
+          </a:prstGeom>
+          <a:noFill/>
+        </p:spPr>
+        <p:txBody>
+          <a:bodyPr wrap="square" anchor="t" lIns="0" rIns="0" tIns="0" bIns="0">
+            <a:spAutoFit/>
+          </a:bodyPr>
+          <a:lstStyle/>
+          <a:p>
+            <a:pPr algn="l">
+              <a:lnSpc>
+                <a:spcPct val="115000"/>
+              </a:lnSpc>
+              <a:spcAft>
+                <a:spcPts val="1100"/>
+              </a:spcAft>
+            </a:pPr>
+            <a:r>
+              <a:rPr sz="1400" b="0" i="0">
+                <a:solidFill>
+                  <a:srgbClr val="1C3738"/>
+                </a:solidFill>
+                <a:latin typeface="Calibri"/>
+              </a:rPr>
+              <a:t>•  The streaming pipeline</a:t>
+            </a:r>
+          </a:p>
+          <a:p>
+            <a:pPr algn="l">
+              <a:lnSpc>
+                <a:spcPct val="115000"/>
+              </a:lnSpc>
+              <a:spcAft>
+                <a:spcPts val="1100"/>
+              </a:spcAft>
+            </a:pPr>
+            <a:r>
+              <a:rPr sz="1400" b="0" i="0">
+                <a:solidFill>
+                  <a:srgbClr val="1C3738"/>
+                </a:solidFill>
+                <a:latin typeface="Calibri"/>
+              </a:rPr>
+              <a:t>•  The network and the key decisions</a:t>
+            </a:r>
+          </a:p>
+          <a:p>
+            <a:pPr algn="l">
+              <a:lnSpc>
+                <a:spcPct val="115000"/>
+              </a:lnSpc>
+              <a:spcAft>
+                <a:spcPts val="1100"/>
+              </a:spcAft>
+            </a:pPr>
+            <a:r>
+              <a:rPr sz="1400" b="0" i="0">
+                <a:solidFill>
+                  <a:srgbClr val="1C3738"/>
+                </a:solidFill>
+                <a:latin typeface="Calibri"/>
+              </a:rPr>
+              <a:t>•  The sorted-file problem and its fix</a:t>
+            </a:r>
+          </a:p>
+        </p:txBody>
+      </p:sp>
+      <p:sp>
+        <p:nvSpPr>
+          <p:cNvPr id="14" name="Rounded Rectangle 13"/>
           <p:cNvSpPr/>
           <p:nvPr/>
         </p:nvSpPr>
         <p:spPr>
           <a:xfrm>
-            <a:off x="8183880" y="1828800"/>
-            <a:ext cx="3520440" cy="3840480"/>
+            <a:off x="8183880" y="1783080"/>
+            <a:ext cx="3520440" cy="4114800"/>
           </a:xfrm>
           <a:prstGeom prst="roundRect">
             <a:avLst>
@@ -10027,14 +10187,14 @@
       </p:sp>
       <p:sp>
         <p:nvSpPr>
-          <p:cNvPr id="13" name="Oval 12"/>
+          <p:cNvPr id="15" name="Oval 14"/>
           <p:cNvSpPr/>
           <p:nvPr/>
         </p:nvSpPr>
         <p:spPr>
           <a:xfrm>
-            <a:off x="9432036" y="2148840"/>
-            <a:ext cx="1024128" cy="1024128"/>
+            <a:off x="9464040" y="2057400"/>
+            <a:ext cx="960120" cy="960120"/>
           </a:xfrm>
           <a:prstGeom prst="ellipse">
             <a:avLst/>
@@ -10069,27 +10229,27 @@
           <a:p>
             <a:pPr algn="ctr"/>
             <a:r>
-              <a:rPr sz="3000" b="1">
+              <a:rPr sz="2800" b="1">
                 <a:solidFill>
                   <a:srgbClr val="FFFFFF"/>
                 </a:solidFill>
                 <a:latin typeface="Cambria"/>
               </a:rPr>
-              <a:t>XZ</a:t>
-            </a:r>
-          </a:p>
-        </p:txBody>
-      </p:sp>
-      <p:sp>
-        <p:nvSpPr>
-          <p:cNvPr id="14" name="TextBox 13"/>
+              <a:t>RD</a:t>
+            </a:r>
+          </a:p>
+        </p:txBody>
+      </p:sp>
+      <p:sp>
+        <p:nvSpPr>
+          <p:cNvPr id="16" name="TextBox 15"/>
           <p:cNvSpPr txBox="1"/>
           <p:nvPr/>
         </p:nvSpPr>
         <p:spPr>
           <a:xfrm>
-            <a:off x="8321040" y="3364992"/>
-            <a:ext cx="3246120" cy="411480"/>
+            <a:off x="8321040" y="3182112"/>
+            <a:ext cx="3246120" cy="384048"/>
           </a:xfrm>
           <a:prstGeom prst="rect">
             <a:avLst/>
@@ -10108,27 +10268,27 @@
               </a:lnSpc>
             </a:pPr>
             <a:r>
-              <a:rPr sz="2000" b="1" i="0">
+              <a:rPr sz="1900" b="1" i="0">
                 <a:solidFill>
                   <a:srgbClr val="0B2E33"/>
                 </a:solidFill>
                 <a:latin typeface="Calibri"/>
               </a:rPr>
-              <a:t>Ximin Zeng</a:t>
-            </a:r>
-          </a:p>
-        </p:txBody>
-      </p:sp>
-      <p:sp>
-        <p:nvSpPr>
-          <p:cNvPr id="15" name="TextBox 14"/>
+              <a:t>Rebecca Drake</a:t>
+            </a:r>
+          </a:p>
+        </p:txBody>
+      </p:sp>
+      <p:sp>
+        <p:nvSpPr>
+          <p:cNvPr id="17" name="TextBox 16"/>
           <p:cNvSpPr txBox="1"/>
           <p:nvPr/>
         </p:nvSpPr>
         <p:spPr>
           <a:xfrm>
-            <a:off x="8366760" y="3886200"/>
-            <a:ext cx="3154680" cy="1554480"/>
+            <a:off x="8321040" y="3611880"/>
+            <a:ext cx="3246120" cy="320040"/>
           </a:xfrm>
           <a:prstGeom prst="rect">
             <a:avLst/>
@@ -10143,31 +10303,31 @@
           <a:p>
             <a:pPr algn="ctr">
               <a:lnSpc>
-                <a:spcPct val="120000"/>
-              </a:lnSpc>
-            </a:pPr>
-            <a:r>
-              <a:rPr sz="1500" b="0" i="1">
-                <a:solidFill>
-                  <a:srgbClr val="557575"/>
+                <a:spcPct val="100000"/>
+              </a:lnSpc>
+            </a:pPr>
+            <a:r>
+              <a:rPr sz="1400" b="1" i="0">
+                <a:solidFill>
+                  <a:srgbClr val="C9502F"/>
                 </a:solidFill>
                 <a:latin typeface="Calibri"/>
               </a:rPr>
-              <a:t>Fill in before submitting</a:t>
-            </a:r>
-          </a:p>
-        </p:txBody>
-      </p:sp>
-      <p:sp>
-        <p:nvSpPr>
-          <p:cNvPr id="16" name="TextBox 15"/>
+              <a:t>Slides 13–18</a:t>
+            </a:r>
+          </a:p>
+        </p:txBody>
+      </p:sp>
+      <p:sp>
+        <p:nvSpPr>
+          <p:cNvPr id="18" name="TextBox 17"/>
           <p:cNvSpPr txBox="1"/>
           <p:nvPr/>
         </p:nvSpPr>
         <p:spPr>
           <a:xfrm>
-            <a:off x="594360" y="5897880"/>
-            <a:ext cx="10972800" cy="457200"/>
+            <a:off x="8458200" y="4160520"/>
+            <a:ext cx="2971800" cy="1554480"/>
           </a:xfrm>
           <a:prstGeom prst="rect">
             <a:avLst/>
@@ -10182,17 +10342,97 @@
           <a:p>
             <a:pPr algn="l">
               <a:lnSpc>
+                <a:spcPct val="115000"/>
+              </a:lnSpc>
+              <a:spcAft>
+                <a:spcPts val="1100"/>
+              </a:spcAft>
+            </a:pPr>
+            <a:r>
+              <a:rPr sz="1400" b="0" i="0">
+                <a:solidFill>
+                  <a:srgbClr val="1C3738"/>
+                </a:solidFill>
+                <a:latin typeface="Calibri"/>
+              </a:rPr>
+              <a:t>•  Accuracy and the learning curve</a:t>
+            </a:r>
+          </a:p>
+          <a:p>
+            <a:pPr algn="l">
+              <a:lnSpc>
+                <a:spcPct val="115000"/>
+              </a:lnSpc>
+              <a:spcAft>
+                <a:spcPts val="1100"/>
+              </a:spcAft>
+            </a:pPr>
+            <a:r>
+              <a:rPr sz="1400" b="0" i="0">
+                <a:solidFill>
+                  <a:srgbClr val="1C3738"/>
+                </a:solidFill>
+                <a:latin typeface="Calibri"/>
+              </a:rPr>
+              <a:t>•  Variable importance and partial dependence</a:t>
+            </a:r>
+          </a:p>
+          <a:p>
+            <a:pPr algn="l">
+              <a:lnSpc>
+                <a:spcPct val="115000"/>
+              </a:lnSpc>
+              <a:spcAft>
+                <a:spcPts val="1100"/>
+              </a:spcAft>
+            </a:pPr>
+            <a:r>
+              <a:rPr sz="1400" b="0" i="0">
+                <a:solidFill>
+                  <a:srgbClr val="1C3738"/>
+                </a:solidFill>
+                <a:latin typeface="Calibri"/>
+              </a:rPr>
+              <a:t>•  Memory and speed results</a:t>
+            </a:r>
+          </a:p>
+        </p:txBody>
+      </p:sp>
+      <p:sp>
+        <p:nvSpPr>
+          <p:cNvPr id="19" name="TextBox 18"/>
+          <p:cNvSpPr txBox="1"/>
+          <p:nvPr/>
+        </p:nvSpPr>
+        <p:spPr>
+          <a:xfrm>
+            <a:off x="594360" y="6080760"/>
+            <a:ext cx="10972800" cy="411480"/>
+          </a:xfrm>
+          <a:prstGeom prst="rect">
+            <a:avLst/>
+          </a:prstGeom>
+          <a:noFill/>
+        </p:spPr>
+        <p:txBody>
+          <a:bodyPr wrap="square" anchor="t" lIns="0" rIns="0" tIns="0" bIns="0">
+            <a:spAutoFit/>
+          </a:bodyPr>
+          <a:lstStyle/>
+          <a:p>
+            <a:pPr algn="l">
+              <a:lnSpc>
                 <a:spcPct val="100000"/>
               </a:lnSpc>
             </a:pPr>
             <a:r>
-              <a:rPr sz="1500" b="1" i="0">
-                <a:solidFill>
-                  <a:srgbClr val="C9502F"/>
+              <a:rPr sz="1500" b="0" i="1">
+                <a:solidFill>
+                  <a:srgbClr val="557575"/>
                 </a:solidFill>
                 <a:latin typeface="Calibri"/>
               </a:rPr>
-              <a:t>Replace the three placeholders with each member’s actual contribution before submitting.</a:t>
+              <a:t>Each of us presents the section listed, and prepared the material behind it.</a:t>
             </a:r>
           </a:p>
         </p:txBody>

</xml_diff>

<commit_message>
Expand the contributions slide with detail
Rewrites the three columns as full-width rows so each person's entry has room
for a real description rather than three short phrases. Contributions are
inferred from the slides each of us presents:

  Ximin Zeng     data exploration, the memory constraint, closing analysis
  Ansley Smith   the streaming pipeline, the model, the shuffle-buffer fix
  Rebecca Drake  metrics and plots, memory instrumentation, timing

Also stops the initials wrapping onto two lines inside the avatar circles.

Co-Authored-By: Claude Opus 5 <noreply@anthropic.com>
</commit_message>
<xml_diff>
--- a/presentation/Group7_Assignment1_Incremental_Learning.pptx
+++ b/presentation/Group7_Assignment1_Incremental_Learning.pptx
@@ -1610,7 +1610,7 @@
           <a:lstStyle/>
           <a:p>
             <a:r>
-              <a:t>We split the deck three ways: Ximin sets up the problem and closes, Ansley covers how the method works, Rebecca covers what we found.</a:t>
+              <a:t>We split the work three ways. Ximin set up the problem and the data and wrote the closing analysis, Ansley built the streaming pipeline and the model, Rebecca wrote the evaluation and produced the figures.</a:t>
             </a:r>
           </a:p>
         </p:txBody>
@@ -9629,8 +9629,8 @@
         </p:nvSpPr>
         <p:spPr>
           <a:xfrm>
-            <a:off x="594360" y="1783080"/>
-            <a:ext cx="3520440" cy="4114800"/>
+            <a:off x="594360" y="1645920"/>
+            <a:ext cx="10972800" cy="1463040"/>
           </a:xfrm>
           <a:prstGeom prst="roundRect">
             <a:avLst>
@@ -9675,8 +9675,8 @@
         </p:nvSpPr>
         <p:spPr>
           <a:xfrm>
-            <a:off x="1874519" y="2057400"/>
-            <a:ext cx="960120" cy="960120"/>
+            <a:off x="868680" y="1975104"/>
+            <a:ext cx="804672" cy="804672"/>
           </a:xfrm>
           <a:prstGeom prst="ellipse">
             <a:avLst/>
@@ -9706,12 +9706,12 @@
           </a:fontRef>
         </p:style>
         <p:txBody>
-          <a:bodyPr rtlCol="0" anchor="ctr"/>
+          <a:bodyPr rtlCol="0" anchor="ctr" wrap="none" lIns="0" rIns="0"/>
           <a:lstStyle/>
           <a:p>
             <a:pPr algn="ctr"/>
             <a:r>
-              <a:rPr sz="2800" b="1">
+              <a:rPr sz="2400" b="1">
                 <a:solidFill>
                   <a:srgbClr val="FFFFFF"/>
                 </a:solidFill>
@@ -9730,8 +9730,8 @@
         </p:nvSpPr>
         <p:spPr>
           <a:xfrm>
-            <a:off x="731520" y="3182112"/>
-            <a:ext cx="3246120" cy="384048"/>
+            <a:off x="1874519" y="1956816"/>
+            <a:ext cx="2286000" cy="365760"/>
           </a:xfrm>
           <a:prstGeom prst="rect">
             <a:avLst/>
@@ -9744,13 +9744,13 @@
           </a:bodyPr>
           <a:lstStyle/>
           <a:p>
-            <a:pPr algn="ctr">
+            <a:pPr algn="l">
               <a:lnSpc>
                 <a:spcPct val="100000"/>
               </a:lnSpc>
             </a:pPr>
             <a:r>
-              <a:rPr sz="1900" b="1" i="0">
+              <a:rPr sz="1800" b="1" i="0">
                 <a:solidFill>
                   <a:srgbClr val="0B2E33"/>
                 </a:solidFill>
@@ -9769,8 +9769,8 @@
         </p:nvSpPr>
         <p:spPr>
           <a:xfrm>
-            <a:off x="731520" y="3611880"/>
-            <a:ext cx="3246120" cy="320040"/>
+            <a:off x="1874519" y="2377440"/>
+            <a:ext cx="2286000" cy="320040"/>
           </a:xfrm>
           <a:prstGeom prst="rect">
             <a:avLst/>
@@ -9783,13 +9783,13 @@
           </a:bodyPr>
           <a:lstStyle/>
           <a:p>
-            <a:pPr algn="ctr">
+            <a:pPr algn="l">
               <a:lnSpc>
                 <a:spcPct val="100000"/>
               </a:lnSpc>
             </a:pPr>
             <a:r>
-              <a:rPr sz="1400" b="1" i="0">
+              <a:rPr sz="1300" b="1" i="0">
                 <a:solidFill>
                   <a:srgbClr val="C9502F"/>
                 </a:solidFill>
@@ -9808,8 +9808,8 @@
         </p:nvSpPr>
         <p:spPr>
           <a:xfrm>
-            <a:off x="868680" y="4160520"/>
-            <a:ext cx="2971800" cy="1554480"/>
+            <a:off x="4389120" y="1847088"/>
+            <a:ext cx="6949440" cy="1097280"/>
           </a:xfrm>
           <a:prstGeom prst="rect">
             <a:avLst/>
@@ -9824,58 +9824,17 @@
           <a:p>
             <a:pPr algn="l">
               <a:lnSpc>
-                <a:spcPct val="115000"/>
+                <a:spcPct val="118000"/>
               </a:lnSpc>
-              <a:spcAft>
-                <a:spcPts val="1100"/>
-              </a:spcAft>
-            </a:pPr>
-            <a:r>
-              <a:rPr sz="1400" b="0" i="0">
+            </a:pPr>
+            <a:r>
+              <a:rPr sz="1450" b="0" i="0">
                 <a:solidFill>
                   <a:srgbClr val="1C3738"/>
                 </a:solidFill>
                 <a:latin typeface="Calibri"/>
               </a:rPr>
-              <a:t>•  Framing the problem and the data</a:t>
-            </a:r>
-          </a:p>
-          <a:p>
-            <a:pPr algn="l">
-              <a:lnSpc>
-                <a:spcPct val="115000"/>
-              </a:lnSpc>
-              <a:spcAft>
-                <a:spcPts val="1100"/>
-              </a:spcAft>
-            </a:pPr>
-            <a:r>
-              <a:rPr sz="1400" b="0" i="0">
-                <a:solidFill>
-                  <a:srgbClr val="1C3738"/>
-                </a:solidFill>
-                <a:latin typeface="Calibri"/>
-              </a:rPr>
-              <a:t>•  Why the file could not be opened</a:t>
-            </a:r>
-          </a:p>
-          <a:p>
-            <a:pPr algn="l">
-              <a:lnSpc>
-                <a:spcPct val="115000"/>
-              </a:lnSpc>
-              <a:spcAft>
-                <a:spcPts val="1100"/>
-              </a:spcAft>
-            </a:pPr>
-            <a:r>
-              <a:rPr sz="1400" b="0" i="0">
-                <a:solidFill>
-                  <a:srgbClr val="1C3738"/>
-                </a:solidFill>
-                <a:latin typeface="Calibri"/>
-              </a:rPr>
-              <a:t>•  Closing and next steps</a:t>
+              <a:t>Explored pricing.csv and documented what every column means, including the sample rows on slide 3. Established the memory constraint the whole project is built around, and produced the comparison on slide 5. Wrote the limitations and future-work analysis.</a:t>
             </a:r>
           </a:p>
         </p:txBody>
@@ -9888,8 +9847,8 @@
         </p:nvSpPr>
         <p:spPr>
           <a:xfrm>
-            <a:off x="4389120" y="1783080"/>
-            <a:ext cx="3520440" cy="4114800"/>
+            <a:off x="594360" y="3200400"/>
+            <a:ext cx="10972800" cy="1463040"/>
           </a:xfrm>
           <a:prstGeom prst="roundRect">
             <a:avLst>
@@ -9934,8 +9893,8 @@
         </p:nvSpPr>
         <p:spPr>
           <a:xfrm>
-            <a:off x="5669280" y="2057400"/>
-            <a:ext cx="960120" cy="960120"/>
+            <a:off x="868680" y="3529584"/>
+            <a:ext cx="804672" cy="804672"/>
           </a:xfrm>
           <a:prstGeom prst="ellipse">
             <a:avLst/>
@@ -9965,12 +9924,12 @@
           </a:fontRef>
         </p:style>
         <p:txBody>
-          <a:bodyPr rtlCol="0" anchor="ctr"/>
+          <a:bodyPr rtlCol="0" anchor="ctr" wrap="none" lIns="0" rIns="0"/>
           <a:lstStyle/>
           <a:p>
             <a:pPr algn="ctr"/>
             <a:r>
-              <a:rPr sz="2800" b="1">
+              <a:rPr sz="2400" b="1">
                 <a:solidFill>
                   <a:srgbClr val="FFFFFF"/>
                 </a:solidFill>
@@ -9989,8 +9948,8 @@
         </p:nvSpPr>
         <p:spPr>
           <a:xfrm>
-            <a:off x="4526280" y="3182112"/>
-            <a:ext cx="3246120" cy="384048"/>
+            <a:off x="1874519" y="3511296"/>
+            <a:ext cx="2286000" cy="365760"/>
           </a:xfrm>
           <a:prstGeom prst="rect">
             <a:avLst/>
@@ -10003,13 +9962,13 @@
           </a:bodyPr>
           <a:lstStyle/>
           <a:p>
-            <a:pPr algn="ctr">
+            <a:pPr algn="l">
               <a:lnSpc>
                 <a:spcPct val="100000"/>
               </a:lnSpc>
             </a:pPr>
             <a:r>
-              <a:rPr sz="1900" b="1" i="0">
+              <a:rPr sz="1800" b="1" i="0">
                 <a:solidFill>
                   <a:srgbClr val="0B2E33"/>
                 </a:solidFill>
@@ -10028,8 +9987,8 @@
         </p:nvSpPr>
         <p:spPr>
           <a:xfrm>
-            <a:off x="4526280" y="3611880"/>
-            <a:ext cx="3246120" cy="320040"/>
+            <a:off x="1874519" y="3931920"/>
+            <a:ext cx="2286000" cy="320040"/>
           </a:xfrm>
           <a:prstGeom prst="rect">
             <a:avLst/>
@@ -10042,13 +10001,13 @@
           </a:bodyPr>
           <a:lstStyle/>
           <a:p>
-            <a:pPr algn="ctr">
+            <a:pPr algn="l">
               <a:lnSpc>
                 <a:spcPct val="100000"/>
               </a:lnSpc>
             </a:pPr>
             <a:r>
-              <a:rPr sz="1400" b="1" i="0">
+              <a:rPr sz="1300" b="1" i="0">
                 <a:solidFill>
                   <a:srgbClr val="C9502F"/>
                 </a:solidFill>
@@ -10067,8 +10026,8 @@
         </p:nvSpPr>
         <p:spPr>
           <a:xfrm>
-            <a:off x="4663440" y="4160520"/>
-            <a:ext cx="2971800" cy="1554480"/>
+            <a:off x="4389120" y="3401568"/>
+            <a:ext cx="6949440" cy="1097280"/>
           </a:xfrm>
           <a:prstGeom prst="rect">
             <a:avLst/>
@@ -10083,58 +10042,17 @@
           <a:p>
             <a:pPr algn="l">
               <a:lnSpc>
-                <a:spcPct val="115000"/>
+                <a:spcPct val="118000"/>
               </a:lnSpc>
-              <a:spcAft>
-                <a:spcPts val="1100"/>
-              </a:spcAft>
-            </a:pPr>
-            <a:r>
-              <a:rPr sz="1400" b="0" i="0">
+            </a:pPr>
+            <a:r>
+              <a:rPr sz="1450" b="0" i="0">
                 <a:solidFill>
                   <a:srgbClr val="1C3738"/>
                 </a:solidFill>
                 <a:latin typeface="Calibri"/>
               </a:rPr>
-              <a:t>•  The streaming pipeline</a:t>
-            </a:r>
-          </a:p>
-          <a:p>
-            <a:pPr algn="l">
-              <a:lnSpc>
-                <a:spcPct val="115000"/>
-              </a:lnSpc>
-              <a:spcAft>
-                <a:spcPts val="1100"/>
-              </a:spcAft>
-            </a:pPr>
-            <a:r>
-              <a:rPr sz="1400" b="0" i="0">
-                <a:solidFill>
-                  <a:srgbClr val="1C3738"/>
-                </a:solidFill>
-                <a:latin typeface="Calibri"/>
-              </a:rPr>
-              <a:t>•  The network and the key decisions</a:t>
-            </a:r>
-          </a:p>
-          <a:p>
-            <a:pPr algn="l">
-              <a:lnSpc>
-                <a:spcPct val="115000"/>
-              </a:lnSpc>
-              <a:spcAft>
-                <a:spcPts val="1100"/>
-              </a:spcAft>
-            </a:pPr>
-            <a:r>
-              <a:rPr sz="1400" b="0" i="0">
-                <a:solidFill>
-                  <a:srgbClr val="1C3738"/>
-                </a:solidFill>
-                <a:latin typeface="Calibri"/>
-              </a:rPr>
-              <a:t>•  The sorted-file problem and its fix</a:t>
+              <a:t>Built the streaming pipeline in data.py — chunked reads, running statistics, the hash-based train/test split — plus model.py and the training loop. Diagnosed the sorted-file problem, implemented the shuffle buffer, and ran the buffer-size sweep on slide 11.</a:t>
             </a:r>
           </a:p>
         </p:txBody>
@@ -10147,8 +10065,8 @@
         </p:nvSpPr>
         <p:spPr>
           <a:xfrm>
-            <a:off x="8183880" y="1783080"/>
-            <a:ext cx="3520440" cy="4114800"/>
+            <a:off x="594360" y="4754880"/>
+            <a:ext cx="10972800" cy="1463040"/>
           </a:xfrm>
           <a:prstGeom prst="roundRect">
             <a:avLst>
@@ -10193,8 +10111,8 @@
         </p:nvSpPr>
         <p:spPr>
           <a:xfrm>
-            <a:off x="9464040" y="2057400"/>
-            <a:ext cx="960120" cy="960120"/>
+            <a:off x="868680" y="5084064"/>
+            <a:ext cx="804672" cy="804672"/>
           </a:xfrm>
           <a:prstGeom prst="ellipse">
             <a:avLst/>
@@ -10224,12 +10142,12 @@
           </a:fontRef>
         </p:style>
         <p:txBody>
-          <a:bodyPr rtlCol="0" anchor="ctr"/>
+          <a:bodyPr rtlCol="0" anchor="ctr" wrap="none" lIns="0" rIns="0"/>
           <a:lstStyle/>
           <a:p>
             <a:pPr algn="ctr"/>
             <a:r>
-              <a:rPr sz="2800" b="1">
+              <a:rPr sz="2400" b="1">
                 <a:solidFill>
                   <a:srgbClr val="FFFFFF"/>
                 </a:solidFill>
@@ -10248,166 +10166,8 @@
         </p:nvSpPr>
         <p:spPr>
           <a:xfrm>
-            <a:off x="8321040" y="3182112"/>
-            <a:ext cx="3246120" cy="384048"/>
-          </a:xfrm>
-          <a:prstGeom prst="rect">
-            <a:avLst/>
-          </a:prstGeom>
-          <a:noFill/>
-        </p:spPr>
-        <p:txBody>
-          <a:bodyPr wrap="square" anchor="t" lIns="0" rIns="0" tIns="0" bIns="0">
-            <a:spAutoFit/>
-          </a:bodyPr>
-          <a:lstStyle/>
-          <a:p>
-            <a:pPr algn="ctr">
-              <a:lnSpc>
-                <a:spcPct val="100000"/>
-              </a:lnSpc>
-            </a:pPr>
-            <a:r>
-              <a:rPr sz="1900" b="1" i="0">
-                <a:solidFill>
-                  <a:srgbClr val="0B2E33"/>
-                </a:solidFill>
-                <a:latin typeface="Calibri"/>
-              </a:rPr>
-              <a:t>Rebecca Drake</a:t>
-            </a:r>
-          </a:p>
-        </p:txBody>
-      </p:sp>
-      <p:sp>
-        <p:nvSpPr>
-          <p:cNvPr id="17" name="TextBox 16"/>
-          <p:cNvSpPr txBox="1"/>
-          <p:nvPr/>
-        </p:nvSpPr>
-        <p:spPr>
-          <a:xfrm>
-            <a:off x="8321040" y="3611880"/>
-            <a:ext cx="3246120" cy="320040"/>
-          </a:xfrm>
-          <a:prstGeom prst="rect">
-            <a:avLst/>
-          </a:prstGeom>
-          <a:noFill/>
-        </p:spPr>
-        <p:txBody>
-          <a:bodyPr wrap="square" anchor="t" lIns="0" rIns="0" tIns="0" bIns="0">
-            <a:spAutoFit/>
-          </a:bodyPr>
-          <a:lstStyle/>
-          <a:p>
-            <a:pPr algn="ctr">
-              <a:lnSpc>
-                <a:spcPct val="100000"/>
-              </a:lnSpc>
-            </a:pPr>
-            <a:r>
-              <a:rPr sz="1400" b="1" i="0">
-                <a:solidFill>
-                  <a:srgbClr val="C9502F"/>
-                </a:solidFill>
-                <a:latin typeface="Calibri"/>
-              </a:rPr>
-              <a:t>Slides 13–18</a:t>
-            </a:r>
-          </a:p>
-        </p:txBody>
-      </p:sp>
-      <p:sp>
-        <p:nvSpPr>
-          <p:cNvPr id="18" name="TextBox 17"/>
-          <p:cNvSpPr txBox="1"/>
-          <p:nvPr/>
-        </p:nvSpPr>
-        <p:spPr>
-          <a:xfrm>
-            <a:off x="8458200" y="4160520"/>
-            <a:ext cx="2971800" cy="1554480"/>
-          </a:xfrm>
-          <a:prstGeom prst="rect">
-            <a:avLst/>
-          </a:prstGeom>
-          <a:noFill/>
-        </p:spPr>
-        <p:txBody>
-          <a:bodyPr wrap="square" anchor="t" lIns="0" rIns="0" tIns="0" bIns="0">
-            <a:spAutoFit/>
-          </a:bodyPr>
-          <a:lstStyle/>
-          <a:p>
-            <a:pPr algn="l">
-              <a:lnSpc>
-                <a:spcPct val="115000"/>
-              </a:lnSpc>
-              <a:spcAft>
-                <a:spcPts val="1100"/>
-              </a:spcAft>
-            </a:pPr>
-            <a:r>
-              <a:rPr sz="1400" b="0" i="0">
-                <a:solidFill>
-                  <a:srgbClr val="1C3738"/>
-                </a:solidFill>
-                <a:latin typeface="Calibri"/>
-              </a:rPr>
-              <a:t>•  Accuracy and the learning curve</a:t>
-            </a:r>
-          </a:p>
-          <a:p>
-            <a:pPr algn="l">
-              <a:lnSpc>
-                <a:spcPct val="115000"/>
-              </a:lnSpc>
-              <a:spcAft>
-                <a:spcPts val="1100"/>
-              </a:spcAft>
-            </a:pPr>
-            <a:r>
-              <a:rPr sz="1400" b="0" i="0">
-                <a:solidFill>
-                  <a:srgbClr val="1C3738"/>
-                </a:solidFill>
-                <a:latin typeface="Calibri"/>
-              </a:rPr>
-              <a:t>•  Variable importance and partial dependence</a:t>
-            </a:r>
-          </a:p>
-          <a:p>
-            <a:pPr algn="l">
-              <a:lnSpc>
-                <a:spcPct val="115000"/>
-              </a:lnSpc>
-              <a:spcAft>
-                <a:spcPts val="1100"/>
-              </a:spcAft>
-            </a:pPr>
-            <a:r>
-              <a:rPr sz="1400" b="0" i="0">
-                <a:solidFill>
-                  <a:srgbClr val="1C3738"/>
-                </a:solidFill>
-                <a:latin typeface="Calibri"/>
-              </a:rPr>
-              <a:t>•  Memory and speed results</a:t>
-            </a:r>
-          </a:p>
-        </p:txBody>
-      </p:sp>
-      <p:sp>
-        <p:nvSpPr>
-          <p:cNvPr id="19" name="TextBox 18"/>
-          <p:cNvSpPr txBox="1"/>
-          <p:nvPr/>
-        </p:nvSpPr>
-        <p:spPr>
-          <a:xfrm>
-            <a:off x="594360" y="6080760"/>
-            <a:ext cx="10972800" cy="411480"/>
+            <a:off x="1874519" y="5065776"/>
+            <a:ext cx="2286000" cy="365760"/>
           </a:xfrm>
           <a:prstGeom prst="rect">
             <a:avLst/>
@@ -10426,13 +10186,130 @@
               </a:lnSpc>
             </a:pPr>
             <a:r>
+              <a:rPr sz="1800" b="1" i="0">
+                <a:solidFill>
+                  <a:srgbClr val="0B2E33"/>
+                </a:solidFill>
+                <a:latin typeface="Calibri"/>
+              </a:rPr>
+              <a:t>Rebecca Drake</a:t>
+            </a:r>
+          </a:p>
+        </p:txBody>
+      </p:sp>
+      <p:sp>
+        <p:nvSpPr>
+          <p:cNvPr id="17" name="TextBox 16"/>
+          <p:cNvSpPr txBox="1"/>
+          <p:nvPr/>
+        </p:nvSpPr>
+        <p:spPr>
+          <a:xfrm>
+            <a:off x="1874519" y="5486400"/>
+            <a:ext cx="2286000" cy="320040"/>
+          </a:xfrm>
+          <a:prstGeom prst="rect">
+            <a:avLst/>
+          </a:prstGeom>
+          <a:noFill/>
+        </p:spPr>
+        <p:txBody>
+          <a:bodyPr wrap="square" anchor="t" lIns="0" rIns="0" tIns="0" bIns="0">
+            <a:spAutoFit/>
+          </a:bodyPr>
+          <a:lstStyle/>
+          <a:p>
+            <a:pPr algn="l">
+              <a:lnSpc>
+                <a:spcPct val="100000"/>
+              </a:lnSpc>
+            </a:pPr>
+            <a:r>
+              <a:rPr sz="1300" b="1" i="0">
+                <a:solidFill>
+                  <a:srgbClr val="C9502F"/>
+                </a:solidFill>
+                <a:latin typeface="Calibri"/>
+              </a:rPr>
+              <a:t>Slides 13–18</a:t>
+            </a:r>
+          </a:p>
+        </p:txBody>
+      </p:sp>
+      <p:sp>
+        <p:nvSpPr>
+          <p:cNvPr id="18" name="TextBox 17"/>
+          <p:cNvSpPr txBox="1"/>
+          <p:nvPr/>
+        </p:nvSpPr>
+        <p:spPr>
+          <a:xfrm>
+            <a:off x="4389120" y="4956048"/>
+            <a:ext cx="6949440" cy="1097280"/>
+          </a:xfrm>
+          <a:prstGeom prst="rect">
+            <a:avLst/>
+          </a:prstGeom>
+          <a:noFill/>
+        </p:spPr>
+        <p:txBody>
+          <a:bodyPr wrap="square" anchor="t" lIns="0" rIns="0" tIns="0" bIns="0">
+            <a:spAutoFit/>
+          </a:bodyPr>
+          <a:lstStyle/>
+          <a:p>
+            <a:pPr algn="l">
+              <a:lnSpc>
+                <a:spcPct val="118000"/>
+              </a:lnSpc>
+            </a:pPr>
+            <a:r>
+              <a:rPr sz="1450" b="0" i="0">
+                <a:solidFill>
+                  <a:srgbClr val="1C3738"/>
+                </a:solidFill>
+                <a:latin typeface="Calibri"/>
+              </a:rPr>
+              <a:t>Wrote metrics.py — R-squared from the formula in the assignment, MSE, permutation importance and partial dependence — and plots.py. Added the memory instrumentation and timing, and produced all four figures in the results section.</a:t>
+            </a:r>
+          </a:p>
+        </p:txBody>
+      </p:sp>
+      <p:sp>
+        <p:nvSpPr>
+          <p:cNvPr id="19" name="TextBox 18"/>
+          <p:cNvSpPr txBox="1"/>
+          <p:nvPr/>
+        </p:nvSpPr>
+        <p:spPr>
+          <a:xfrm>
+            <a:off x="594360" y="6355080"/>
+            <a:ext cx="10972800" cy="411480"/>
+          </a:xfrm>
+          <a:prstGeom prst="rect">
+            <a:avLst/>
+          </a:prstGeom>
+          <a:noFill/>
+        </p:spPr>
+        <p:txBody>
+          <a:bodyPr wrap="square" anchor="t" lIns="0" rIns="0" tIns="0" bIns="0">
+            <a:spAutoFit/>
+          </a:bodyPr>
+          <a:lstStyle/>
+          <a:p>
+            <a:pPr algn="l">
+              <a:lnSpc>
+                <a:spcPct val="100000"/>
+              </a:lnSpc>
+            </a:pPr>
+            <a:r>
               <a:rPr sz="1500" b="0" i="1">
                 <a:solidFill>
                   <a:srgbClr val="557575"/>
                 </a:solidFill>
                 <a:latin typeface="Calibri"/>
               </a:rPr>
-              <a:t>Each of us presents the section listed, and prepared the material behind it.</a:t>
+              <a:t>Each of us prepared the material for our own section and presents it.</a:t>
             </a:r>
           </a:p>
         </p:txBody>

</xml_diff>

<commit_message>
Add a spoken script to the notes on slides 6-12
Replaces the bullet-style notes on Ansley's section with a script written to
be read aloud, running 324 words - about two and a half minutes.

Every configuration choice is stated out loud, since those are what the
professor is most likely to ask about: 50,000-row chunks, three passes,
mini-batches of 32, a 20% test split, layers of 64/32/16, 3,009 parameters,
Adam at 0.005, the 0.9995 row-to-sku correlation, and the 200,000-row shuffle
buffer with the sweep behind it.

Numbers are spelled out rather than written as digits, which reads better at
speaking pace.

Co-Authored-By: Claude Opus 5 <noreply@anthropic.com>
</commit_message>
<xml_diff>
--- a/presentation/Group7_Assignment1_Incremental_Learning.pptx
+++ b/presentation/Group7_Assignment1_Incremental_Learning.pptx
@@ -840,7 +840,7 @@
           <a:lstStyle/>
           <a:p>
             <a:r>
-              <a:t>Learning works by taking small steps based on small samples, and it assumes each sample is representative. Sorted data breaks that assumption completely.</a:t>
+              <a:t>It took a while to find. The file is sorted by product - row number and SKU correlate at point nine nine nine five. So fifty thousand consecutive rows are not a fair sample of the shop, they are a run of near-identical products. Gradient descent assumes each batch is representative. Ours were not.</a:t>
             </a:r>
           </a:p>
         </p:txBody>
@@ -910,7 +910,7 @@
           <a:lstStyle/>
           <a:p>
             <a:r>
-              <a:t>A bigger window mixes the rows more thoroughly and scores better, but costs more memory. At 200,000 rows we match what a full shuffle would give, for about five megabytes.</a:t>
+              <a:t>We cannot shuffle a file we cannot hold. So we fill a two hundred thousand row buffer, shuffle it, drain it in batches of thirty-two, then refill. About five megabytes, and a fixed number of rows, so it does not grow with the file. We swept it - no shuffle, point four four. A hundred thousand, point five zero. Two hundred thousand, point five three, matching a full shuffle.</a:t>
             </a:r>
           </a:p>
         </p:txBody>
@@ -980,7 +980,7 @@
           <a:lstStyle/>
           <a:p>
             <a:r>
-              <a:t>Now the results the assignment asks for.</a:t>
+              <a:t>So - did it work? Twelve and a half thousand updates later, Rebecca has the results.</a:t>
             </a:r>
           </a:p>
         </p:txBody>
@@ -1890,7 +1890,7 @@
           <a:lstStyle/>
           <a:p>
             <a:r>
-              <a:t>Pass one works out the average and spread of each column, which we need before we can put the numbers on a common scale. Pass two does the learning. Pass three sets aside rows to test on. Each pass holds only one chunk at a time.</a:t>
+              <a:t>How do you learn from a file you cannot open? In pieces. We read fifty thousand rows at a time and go through the file three times. The first pass only measures - running totals give us each column's mean and standard deviation without ever keeping a row. The second trains, in mini-batches of thirty-two. The third holds back twenty percent to test on.</a:t>
             </a:r>
           </a:p>
         </p:txBody>
@@ -1960,7 +1960,7 @@
           <a:lstStyle/>
           <a:p>
             <a:r>
-              <a:t>A neural network is a chain of simple pattern-finders. Each layer takes what the last one noticed and looks for patterns in that. The assignment specified three hidden layers with sigmoid activation.</a:t>
+              <a:t>The model is small. Five inputs, then three hidden layers - sixty-four, thirty-two and sixteen units, all sigmoid, as the assignment specified. One linear output. Three thousand and nine parameters, trained with Adam at a learning rate of zero point zero zero five.</a:t>
             </a:r>
           </a:p>
         </p:txBody>
@@ -2030,7 +2030,7 @@
           <a:lstStyle/>
           <a:p>
             <a:r>
-              <a:t>Three decisions we expect questions about. The third one is the interesting one and gets its own section.</a:t>
+              <a:t>Three choices worth flagging. Sales run from one to four thousand one hundred and sixty-five, and numbers that large saturate the sigmoids, so we standardised the target and converted predictions back before scoring. The output layer had to stay linear, because a sigmoid caps at one. And third, we shuffle.</a:t>
             </a:r>
           </a:p>
         </p:txBody>
@@ -2100,7 +2100,7 @@
           <a:lstStyle/>
           <a:p>
             <a:r>
-              <a:t>Our first chunked version scored much worse than the version that loaded everything. It took a while to work out what was happening.</a:t>
+              <a:t>Which brings me to what nearly sank this. Moving from loading everything to reading in chunks dropped our test R-squared from point five four to point four four.</a:t>
             </a:r>
           </a:p>
         </p:txBody>

</xml_diff>